<commit_message>
Targeted fixes per user feedback batch 2
- 데모: "본 연구 모델 예측 범위" 카드 완전 제거
- 데모: errorCurve를 voxel mismatch ratio로 교체 (단조 증가 보장)
       absDphi는 binarize 후 비단조 가능 → 학생 직관 해침
- 데모: hero sub/캡션을 학생 직관용으로 단순화
- Try-it / 한 문장씩 관찰 / 학습 방식 셀 / tri-axis W1 잔여 / 정답 박스 / fork하여 — 모두 정조준 제거 (0건 grep 확인)
- handout/README의 학습 흐름(90분) 시간표 제거
- W1 g1 handout Isotropy 정의 부드럽게
- PPT 본문 폰트 19→17, 18→16 — 한국어 줄바꿈 안전성
- 세 축 슬라이스 figure를 CastleGate(불균질)로 + 다양한 인덱스 (z=80, y=200, x=50) — 시각 차이 명확
- helpers (dr_utils, model_utils) 깔끔한 docstring으로 재작성
- 데이터 인코딩 검증: BB φ=22% → pore=1, solid=0 확정
</commit_message>
<xml_diff>
--- a/group1_advanced/week1/slides/W1_group1.pptx
+++ b/group1_advanced/week1/slides/W1_group1.pptx
@@ -4028,7 +4028,7 @@
               </a:spcAft>
             </a:pPr>
             <a:r>
-              <a:rPr sz="1800" b="0">
+              <a:rPr sz="1600" b="0">
                 <a:solidFill>
                   <a:srgbClr val="EA851B"/>
                 </a:solidFill>
@@ -4037,7 +4037,7 @@
               <a:t>•  </a:t>
             </a:r>
             <a:r>
-              <a:rPr sz="1800" b="0">
+              <a:rPr sz="1600" b="0">
                 <a:solidFill>
                   <a:srgbClr val="181818"/>
                 </a:solidFill>
@@ -4056,7 +4056,7 @@
               </a:spcAft>
             </a:pPr>
             <a:r>
-              <a:rPr sz="1800" b="0">
+              <a:rPr sz="1600" b="0">
                 <a:solidFill>
                   <a:srgbClr val="EA851B"/>
                 </a:solidFill>
@@ -4065,7 +4065,7 @@
               <a:t>•  </a:t>
             </a:r>
             <a:r>
-              <a:rPr sz="1800" b="0">
+              <a:rPr sz="1600" b="0">
                 <a:solidFill>
                   <a:srgbClr val="181818"/>
                 </a:solidFill>
@@ -4084,7 +4084,7 @@
               </a:spcAft>
             </a:pPr>
             <a:r>
-              <a:rPr sz="1800" b="0">
+              <a:rPr sz="1600" b="0">
                 <a:solidFill>
                   <a:srgbClr val="EA851B"/>
                 </a:solidFill>
@@ -4093,7 +4093,7 @@
               <a:t>•  </a:t>
             </a:r>
             <a:r>
-              <a:rPr sz="1800" b="0">
+              <a:rPr sz="1600" b="0">
                 <a:solidFill>
                   <a:srgbClr val="181818"/>
                 </a:solidFill>
@@ -4112,7 +4112,7 @@
               </a:spcAft>
             </a:pPr>
             <a:r>
-              <a:rPr sz="1800" b="0">
+              <a:rPr sz="1600" b="0">
                 <a:solidFill>
                   <a:srgbClr val="EA851B"/>
                 </a:solidFill>
@@ -4121,7 +4121,7 @@
               <a:t>•  </a:t>
             </a:r>
             <a:r>
-              <a:rPr sz="1800" b="0">
+              <a:rPr sz="1600" b="0">
                 <a:solidFill>
                   <a:srgbClr val="181818"/>
                 </a:solidFill>
@@ -4460,7 +4460,7 @@
               </a:spcAft>
             </a:pPr>
             <a:r>
-              <a:rPr sz="1800" b="0">
+              <a:rPr sz="1600" b="0">
                 <a:solidFill>
                   <a:srgbClr val="EA851B"/>
                 </a:solidFill>
@@ -4469,7 +4469,7 @@
               <a:t>•  </a:t>
             </a:r>
             <a:r>
-              <a:rPr sz="1800" b="0">
+              <a:rPr sz="1600" b="0">
                 <a:solidFill>
                   <a:srgbClr val="181818"/>
                 </a:solidFill>
@@ -4488,7 +4488,7 @@
               </a:spcAft>
             </a:pPr>
             <a:r>
-              <a:rPr sz="1800" b="0">
+              <a:rPr sz="1600" b="0">
                 <a:solidFill>
                   <a:srgbClr val="EA851B"/>
                 </a:solidFill>
@@ -4497,7 +4497,7 @@
               <a:t>•  </a:t>
             </a:r>
             <a:r>
-              <a:rPr sz="1800" b="0">
+              <a:rPr sz="1600" b="0">
                 <a:solidFill>
                   <a:srgbClr val="181818"/>
                 </a:solidFill>
@@ -4516,7 +4516,7 @@
               </a:spcAft>
             </a:pPr>
             <a:r>
-              <a:rPr sz="1800" b="0">
+              <a:rPr sz="1600" b="0">
                 <a:solidFill>
                   <a:srgbClr val="EA851B"/>
                 </a:solidFill>
@@ -4525,7 +4525,7 @@
               <a:t>•  </a:t>
             </a:r>
             <a:r>
-              <a:rPr sz="1800" b="0">
+              <a:rPr sz="1600" b="0">
                 <a:solidFill>
                   <a:srgbClr val="181818"/>
                 </a:solidFill>
@@ -4544,7 +4544,7 @@
               </a:spcAft>
             </a:pPr>
             <a:r>
-              <a:rPr sz="1800" b="0">
+              <a:rPr sz="1600" b="0">
                 <a:solidFill>
                   <a:srgbClr val="EA851B"/>
                 </a:solidFill>
@@ -4553,7 +4553,7 @@
               <a:t>•  </a:t>
             </a:r>
             <a:r>
-              <a:rPr sz="1800" b="0">
+              <a:rPr sz="1600" b="0">
                 <a:solidFill>
                   <a:srgbClr val="181818"/>
                 </a:solidFill>
@@ -5753,7 +5753,7 @@
               </a:spcAft>
             </a:pPr>
             <a:r>
-              <a:rPr sz="1900" b="0">
+              <a:rPr sz="1700" b="0">
                 <a:solidFill>
                   <a:srgbClr val="EA851B"/>
                 </a:solidFill>
@@ -5762,7 +5762,7 @@
               <a:t>•  </a:t>
             </a:r>
             <a:r>
-              <a:rPr sz="1900" b="0">
+              <a:rPr sz="1700" b="0">
                 <a:solidFill>
                   <a:srgbClr val="181818"/>
                 </a:solidFill>
@@ -5781,7 +5781,7 @@
               </a:spcAft>
             </a:pPr>
             <a:r>
-              <a:rPr sz="1900" b="0">
+              <a:rPr sz="1700" b="0">
                 <a:solidFill>
                   <a:srgbClr val="EA851B"/>
                 </a:solidFill>
@@ -5790,7 +5790,7 @@
               <a:t>•  </a:t>
             </a:r>
             <a:r>
-              <a:rPr sz="1900" b="0">
+              <a:rPr sz="1700" b="0">
                 <a:solidFill>
                   <a:srgbClr val="181818"/>
                 </a:solidFill>
@@ -5809,7 +5809,7 @@
               </a:spcAft>
             </a:pPr>
             <a:r>
-              <a:rPr sz="1900" b="0">
+              <a:rPr sz="1700" b="0">
                 <a:solidFill>
                   <a:srgbClr val="EA851B"/>
                 </a:solidFill>
@@ -5818,7 +5818,7 @@
               <a:t>•  </a:t>
             </a:r>
             <a:r>
-              <a:rPr sz="1900" b="0">
+              <a:rPr sz="1700" b="0">
                 <a:solidFill>
                   <a:srgbClr val="181818"/>
                 </a:solidFill>
@@ -5837,7 +5837,7 @@
               </a:spcAft>
             </a:pPr>
             <a:r>
-              <a:rPr sz="1900" b="0">
+              <a:rPr sz="1700" b="0">
                 <a:solidFill>
                   <a:srgbClr val="EA851B"/>
                 </a:solidFill>
@@ -5846,7 +5846,7 @@
               <a:t>•  </a:t>
             </a:r>
             <a:r>
-              <a:rPr sz="1900" b="0">
+              <a:rPr sz="1700" b="0">
                 <a:solidFill>
                   <a:srgbClr val="181818"/>
                 </a:solidFill>
@@ -5865,7 +5865,7 @@
               </a:spcAft>
             </a:pPr>
             <a:r>
-              <a:rPr sz="1900" b="0">
+              <a:rPr sz="1700" b="0">
                 <a:solidFill>
                   <a:srgbClr val="EA851B"/>
                 </a:solidFill>
@@ -5874,7 +5874,7 @@
               <a:t>•  </a:t>
             </a:r>
             <a:r>
-              <a:rPr sz="1900" b="0">
+              <a:rPr sz="1700" b="0">
                 <a:solidFill>
                   <a:srgbClr val="181818"/>
                 </a:solidFill>
@@ -6824,7 +6824,7 @@
                 </a:solidFill>
                 <a:latin typeface="Pretendard Black"/>
               </a:rPr>
-              <a:t>같은 부피의 세 축 슬라이스 (BB)</a:t>
+              <a:t>같은 부피의 세 축 슬라이스 (CastleGate)</a:t>
             </a:r>
           </a:p>
         </p:txBody>
@@ -6982,8 +6982,8 @@
         </p:nvSpPr>
         <p:spPr>
           <a:xfrm>
-            <a:off x="731520" y="5486400"/>
-            <a:ext cx="10972800" cy="457200"/>
+            <a:off x="365760" y="5486400"/>
+            <a:ext cx="11430000" cy="457200"/>
           </a:xfrm>
           <a:prstGeom prst="rect">
             <a:avLst/>
@@ -7002,52 +7002,13 @@
               </a:lnSpc>
             </a:pPr>
             <a:r>
-              <a:rPr sz="1500" b="0">
+              <a:rPr sz="1400" b="0">
                 <a:solidFill>
                   <a:srgbClr val="181818"/>
                 </a:solidFill>
                 <a:latin typeface="Pretendard SemiBold"/>
               </a:rPr>
-              <a:t>동일 부피를 z · y · x 세 직교 평면으로 자른 결과. 통계는 유사하지만 세부 패턴은 서로 다름.</a:t>
-            </a:r>
-          </a:p>
-        </p:txBody>
-      </p:sp>
-      <p:sp>
-        <p:nvSpPr>
-          <p:cNvPr id="8" name="TextBox 7"/>
-          <p:cNvSpPr txBox="1"/>
-          <p:nvPr/>
-        </p:nvSpPr>
-        <p:spPr>
-          <a:xfrm>
-            <a:off x="731520" y="5943600"/>
-            <a:ext cx="10972800" cy="457200"/>
-          </a:xfrm>
-          <a:prstGeom prst="rect">
-            <a:avLst/>
-          </a:prstGeom>
-          <a:noFill/>
-        </p:spPr>
-        <p:txBody>
-          <a:bodyPr wrap="square" lIns="45720" rIns="45720">
-            <a:spAutoFit/>
-          </a:bodyPr>
-          <a:lstStyle/>
-          <a:p>
-            <a:pPr algn="l">
-              <a:lnSpc>
-                <a:spcPct val="115000"/>
-              </a:lnSpc>
-            </a:pPr>
-            <a:r>
-              <a:rPr sz="1400" b="0">
-                <a:solidFill>
-                  <a:srgbClr val="7A7A7A"/>
-                </a:solidFill>
-                <a:latin typeface="Pretendard Medium"/>
-              </a:rPr>
-              <a:t>→ W5의 tri-axis 기법은 세 축의 보완적 정보를 융합해 2.5D 방식으로 3D 부피를 복원합니다.</a:t>
+              <a:t>동일 부피를 z · y · x 세 직교 평면으로 자른 결과. 슬라이스 위치도 모두 다르며, 세부 공극 패턴이 서로 다릅니다.</a:t>
             </a:r>
           </a:p>
         </p:txBody>
@@ -7261,7 +7222,7 @@
               </a:spcAft>
             </a:pPr>
             <a:r>
-              <a:rPr sz="1800" b="0">
+              <a:rPr sz="1600" b="0">
                 <a:solidFill>
                   <a:srgbClr val="EA851B"/>
                 </a:solidFill>
@@ -7270,7 +7231,7 @@
               <a:t>•  </a:t>
             </a:r>
             <a:r>
-              <a:rPr sz="1800" b="0">
+              <a:rPr sz="1600" b="0">
                 <a:solidFill>
                   <a:srgbClr val="181818"/>
                 </a:solidFill>
@@ -7289,7 +7250,7 @@
               </a:spcAft>
             </a:pPr>
             <a:r>
-              <a:rPr sz="1800" b="0">
+              <a:rPr sz="1600" b="0">
                 <a:solidFill>
                   <a:srgbClr val="EA851B"/>
                 </a:solidFill>
@@ -7298,7 +7259,7 @@
               <a:t>•  </a:t>
             </a:r>
             <a:r>
-              <a:rPr sz="1800" b="0">
+              <a:rPr sz="1600" b="0">
                 <a:solidFill>
                   <a:srgbClr val="181818"/>
                 </a:solidFill>
@@ -7317,7 +7278,7 @@
               </a:spcAft>
             </a:pPr>
             <a:r>
-              <a:rPr sz="1800" b="0">
+              <a:rPr sz="1600" b="0">
                 <a:solidFill>
                   <a:srgbClr val="EA851B"/>
                 </a:solidFill>
@@ -7326,7 +7287,7 @@
               <a:t>•  </a:t>
             </a:r>
             <a:r>
-              <a:rPr sz="1800" b="0">
+              <a:rPr sz="1600" b="0">
                 <a:solidFill>
                   <a:srgbClr val="181818"/>
                 </a:solidFill>
@@ -7345,7 +7306,7 @@
               </a:spcAft>
             </a:pPr>
             <a:r>
-              <a:rPr sz="1800" b="0">
+              <a:rPr sz="1600" b="0">
                 <a:solidFill>
                   <a:srgbClr val="EA851B"/>
                 </a:solidFill>
@@ -7354,7 +7315,7 @@
               <a:t>•  </a:t>
             </a:r>
             <a:r>
-              <a:rPr sz="1800" b="0">
+              <a:rPr sz="1600" b="0">
                 <a:solidFill>
                   <a:srgbClr val="181818"/>
                 </a:solidFill>
@@ -7854,7 +7815,7 @@
               </a:spcAft>
             </a:pPr>
             <a:r>
-              <a:rPr sz="1800" b="0">
+              <a:rPr sz="1600" b="0">
                 <a:solidFill>
                   <a:srgbClr val="EA851B"/>
                 </a:solidFill>
@@ -7863,7 +7824,7 @@
               <a:t>•  </a:t>
             </a:r>
             <a:r>
-              <a:rPr sz="1800" b="0">
+              <a:rPr sz="1600" b="0">
                 <a:solidFill>
                   <a:srgbClr val="181818"/>
                 </a:solidFill>
@@ -7944,7 +7905,7 @@
               </a:spcAft>
             </a:pPr>
             <a:r>
-              <a:rPr sz="1800" b="0">
+              <a:rPr sz="1600" b="0">
                 <a:solidFill>
                   <a:srgbClr val="EA851B"/>
                 </a:solidFill>
@@ -7953,7 +7914,7 @@
               <a:t>•  </a:t>
             </a:r>
             <a:r>
-              <a:rPr sz="1800" b="0">
+              <a:rPr sz="1600" b="0">
                 <a:solidFill>
                   <a:srgbClr val="181818"/>
                 </a:solidFill>
@@ -7972,7 +7933,7 @@
               </a:spcAft>
             </a:pPr>
             <a:r>
-              <a:rPr sz="1800" b="0">
+              <a:rPr sz="1600" b="0">
                 <a:solidFill>
                   <a:srgbClr val="EA851B"/>
                 </a:solidFill>
@@ -7981,7 +7942,7 @@
               <a:t>•  </a:t>
             </a:r>
             <a:r>
-              <a:rPr sz="1800" b="0">
+              <a:rPr sz="1600" b="0">
                 <a:solidFill>
                   <a:srgbClr val="181818"/>
                 </a:solidFill>
@@ -8000,7 +7961,7 @@
               </a:spcAft>
             </a:pPr>
             <a:r>
-              <a:rPr sz="1800" b="0">
+              <a:rPr sz="1600" b="0">
                 <a:solidFill>
                   <a:srgbClr val="EA851B"/>
                 </a:solidFill>
@@ -8009,7 +7970,7 @@
               <a:t>•  </a:t>
             </a:r>
             <a:r>
-              <a:rPr sz="1800" b="0">
+              <a:rPr sz="1600" b="0">
                 <a:solidFill>
                   <a:srgbClr val="181818"/>
                 </a:solidFill>

</xml_diff>